<commit_message>
cambiar colores y tamaño imagenes presentación
</commit_message>
<xml_diff>
--- a/Presentación/Presentación.pptx
+++ b/Presentación/Presentación.pptx
@@ -12,8 +12,8 @@
   </p:handoutMasterIdLst>
   <p:sldIdLst>
     <p:sldId id="310" r:id="rId5"/>
-    <p:sldId id="306" r:id="rId6"/>
-    <p:sldId id="315" r:id="rId7"/>
+    <p:sldId id="315" r:id="rId6"/>
+    <p:sldId id="306" r:id="rId7"/>
     <p:sldId id="316" r:id="rId8"/>
     <p:sldId id="318" r:id="rId9"/>
     <p:sldId id="317" r:id="rId10"/>
@@ -234,7 +234,7 @@
             <a:pPr rtl="0"/>
             <a:fld id="{9347C1C4-E474-4240-93E7-DFB7421C2C11}" type="datetime1">
               <a:rPr lang="es-ES" smtClean="0"/>
-              <a:t>25/06/2026</a:t>
+              <a:t>26/06/2026</a:t>
             </a:fld>
             <a:endParaRPr lang="es-ES" dirty="0"/>
           </a:p>
@@ -416,7 +416,7 @@
             <a:pPr rtl="0"/>
             <a:fld id="{424FCACF-6754-467E-9E88-CC384D668E81}" type="datetime1">
               <a:rPr lang="es-ES" smtClean="0"/>
-              <a:t>25/06/2026</a:t>
+              <a:t>26/06/2026</a:t>
             </a:fld>
             <a:endParaRPr lang="es-ES" dirty="0"/>
           </a:p>
@@ -723,6 +723,13 @@
           </p:nvPr>
         </p:nvSpPr>
         <p:spPr/>
+        <p:txBody>
+          <a:bodyPr/>
+          <a:lstStyle/>
+          <a:p>
+            <a:endParaRPr lang="es-ES" dirty="0"/>
+          </a:p>
+        </p:txBody>
       </p:sp>
       <p:sp>
         <p:nvSpPr>
@@ -790,100 +797,6 @@
 </file>
 
 <file path=ppt/notesSlides/notesSlide2.xml><?xml version="1.0" encoding="utf-8"?>
-<p:notes xmlns:a="http://schemas.openxmlformats.org/drawingml/2006/main" xmlns:r="http://schemas.openxmlformats.org/officeDocument/2006/relationships" xmlns:p="http://schemas.openxmlformats.org/presentationml/2006/main">
-  <p:cSld>
-    <p:spTree>
-      <p:nvGrpSpPr>
-        <p:cNvPr id="1" name=""/>
-        <p:cNvGrpSpPr/>
-        <p:nvPr/>
-      </p:nvGrpSpPr>
-      <p:grpSpPr>
-        <a:xfrm>
-          <a:off x="0" y="0"/>
-          <a:ext cx="0" cy="0"/>
-          <a:chOff x="0" y="0"/>
-          <a:chExt cx="0" cy="0"/>
-        </a:xfrm>
-      </p:grpSpPr>
-      <p:sp>
-        <p:nvSpPr>
-          <p:cNvPr id="2" name="Marcador de imagen de diapositiva 1"/>
-          <p:cNvSpPr>
-            <a:spLocks noGrp="1" noRot="1" noChangeAspect="1"/>
-          </p:cNvSpPr>
-          <p:nvPr>
-            <p:ph type="sldImg"/>
-          </p:nvPr>
-        </p:nvSpPr>
-        <p:spPr/>
-      </p:sp>
-      <p:sp>
-        <p:nvSpPr>
-          <p:cNvPr id="3" name="Marcador de notas 2"/>
-          <p:cNvSpPr>
-            <a:spLocks noGrp="1"/>
-          </p:cNvSpPr>
-          <p:nvPr>
-            <p:ph type="body" idx="1"/>
-          </p:nvPr>
-        </p:nvSpPr>
-        <p:spPr/>
-        <p:txBody>
-          <a:bodyPr rtlCol="0"/>
-          <a:lstStyle>
-            <a:defPPr>
-              <a:defRPr lang="es-ES"/>
-            </a:defPPr>
-          </a:lstStyle>
-          <a:p>
-            <a:pPr rtl="0"/>
-            <a:endParaRPr lang="es-ES" dirty="0"/>
-          </a:p>
-        </p:txBody>
-      </p:sp>
-      <p:sp>
-        <p:nvSpPr>
-          <p:cNvPr id="4" name="Marcador de número de diapositiva 3"/>
-          <p:cNvSpPr>
-            <a:spLocks noGrp="1"/>
-          </p:cNvSpPr>
-          <p:nvPr>
-            <p:ph type="sldNum" sz="quarter" idx="5"/>
-          </p:nvPr>
-        </p:nvSpPr>
-        <p:spPr/>
-        <p:txBody>
-          <a:bodyPr rtlCol="0"/>
-          <a:lstStyle>
-            <a:defPPr>
-              <a:defRPr lang="es-ES"/>
-            </a:defPPr>
-          </a:lstStyle>
-          <a:p>
-            <a:pPr rtl="0"/>
-            <a:fld id="{F5B62BC0-7DC4-4569-951D-2BB9475345C6}" type="slidenum">
-              <a:rPr lang="es-ES" noProof="0" smtClean="0"/>
-              <a:t>2</a:t>
-            </a:fld>
-            <a:endParaRPr lang="es-ES" noProof="0" dirty="0"/>
-          </a:p>
-        </p:txBody>
-      </p:sp>
-    </p:spTree>
-    <p:extLst>
-      <p:ext uri="{BB962C8B-B14F-4D97-AF65-F5344CB8AC3E}">
-        <p14:creationId xmlns:p14="http://schemas.microsoft.com/office/powerpoint/2010/main" val="2867342842"/>
-      </p:ext>
-    </p:extLst>
-  </p:cSld>
-  <p:clrMapOvr>
-    <a:masterClrMapping/>
-  </p:clrMapOvr>
-</p:notes>
-</file>
-
-<file path=ppt/notesSlides/notesSlide3.xml><?xml version="1.0" encoding="utf-8"?>
 <p:notes xmlns:a="http://schemas.openxmlformats.org/drawingml/2006/main" xmlns:r="http://schemas.openxmlformats.org/officeDocument/2006/relationships" xmlns:p="http://schemas.openxmlformats.org/presentationml/2006/main">
   <p:cSld>
     <p:spTree>
@@ -923,6 +836,13 @@
           </p:nvPr>
         </p:nvSpPr>
         <p:spPr/>
+        <p:txBody>
+          <a:bodyPr/>
+          <a:lstStyle/>
+          <a:p>
+            <a:endParaRPr lang="es-ES" dirty="0"/>
+          </a:p>
+        </p:txBody>
       </p:sp>
       <p:sp>
         <p:nvSpPr>
@@ -963,6 +883,107 @@
               </a:ext>
             </a:extLst>
           </p:cNvPr>
+          <p:cNvSpPr>
+            <a:spLocks noGrp="1"/>
+          </p:cNvSpPr>
+          <p:nvPr>
+            <p:ph type="sldNum" sz="quarter" idx="5"/>
+          </p:nvPr>
+        </p:nvSpPr>
+        <p:spPr/>
+        <p:txBody>
+          <a:bodyPr rtlCol="0"/>
+          <a:lstStyle>
+            <a:defPPr>
+              <a:defRPr lang="es-ES"/>
+            </a:defPPr>
+          </a:lstStyle>
+          <a:p>
+            <a:pPr rtl="0"/>
+            <a:fld id="{F5B62BC0-7DC4-4569-951D-2BB9475345C6}" type="slidenum">
+              <a:rPr lang="es-ES" noProof="0" smtClean="0"/>
+              <a:t>2</a:t>
+            </a:fld>
+            <a:endParaRPr lang="es-ES" noProof="0" dirty="0"/>
+          </a:p>
+        </p:txBody>
+      </p:sp>
+    </p:spTree>
+    <p:extLst>
+      <p:ext uri="{BB962C8B-B14F-4D97-AF65-F5344CB8AC3E}">
+        <p14:creationId xmlns:p14="http://schemas.microsoft.com/office/powerpoint/2010/main" val="2108580008"/>
+      </p:ext>
+    </p:extLst>
+  </p:cSld>
+  <p:clrMapOvr>
+    <a:masterClrMapping/>
+  </p:clrMapOvr>
+</p:notes>
+</file>
+
+<file path=ppt/notesSlides/notesSlide3.xml><?xml version="1.0" encoding="utf-8"?>
+<p:notes xmlns:a="http://schemas.openxmlformats.org/drawingml/2006/main" xmlns:r="http://schemas.openxmlformats.org/officeDocument/2006/relationships" xmlns:p="http://schemas.openxmlformats.org/presentationml/2006/main">
+  <p:cSld>
+    <p:spTree>
+      <p:nvGrpSpPr>
+        <p:cNvPr id="1" name=""/>
+        <p:cNvGrpSpPr/>
+        <p:nvPr/>
+      </p:nvGrpSpPr>
+      <p:grpSpPr>
+        <a:xfrm>
+          <a:off x="0" y="0"/>
+          <a:ext cx="0" cy="0"/>
+          <a:chOff x="0" y="0"/>
+          <a:chExt cx="0" cy="0"/>
+        </a:xfrm>
+      </p:grpSpPr>
+      <p:sp>
+        <p:nvSpPr>
+          <p:cNvPr id="2" name="Marcador de imagen de diapositiva 1"/>
+          <p:cNvSpPr>
+            <a:spLocks noGrp="1" noRot="1" noChangeAspect="1"/>
+          </p:cNvSpPr>
+          <p:nvPr>
+            <p:ph type="sldImg"/>
+          </p:nvPr>
+        </p:nvSpPr>
+        <p:spPr/>
+        <p:txBody>
+          <a:bodyPr/>
+          <a:lstStyle/>
+          <a:p>
+            <a:endParaRPr lang="es-ES" dirty="0"/>
+          </a:p>
+        </p:txBody>
+      </p:sp>
+      <p:sp>
+        <p:nvSpPr>
+          <p:cNvPr id="3" name="Marcador de notas 2"/>
+          <p:cNvSpPr>
+            <a:spLocks noGrp="1"/>
+          </p:cNvSpPr>
+          <p:nvPr>
+            <p:ph type="body" idx="1"/>
+          </p:nvPr>
+        </p:nvSpPr>
+        <p:spPr/>
+        <p:txBody>
+          <a:bodyPr rtlCol="0"/>
+          <a:lstStyle>
+            <a:defPPr>
+              <a:defRPr lang="es-ES"/>
+            </a:defPPr>
+          </a:lstStyle>
+          <a:p>
+            <a:pPr rtl="0"/>
+            <a:endParaRPr lang="es-ES" dirty="0"/>
+          </a:p>
+        </p:txBody>
+      </p:sp>
+      <p:sp>
+        <p:nvSpPr>
+          <p:cNvPr id="4" name="Marcador de número de diapositiva 3"/>
           <p:cNvSpPr>
             <a:spLocks noGrp="1"/>
           </p:cNvSpPr>
@@ -991,7 +1012,7 @@
     </p:spTree>
     <p:extLst>
       <p:ext uri="{BB962C8B-B14F-4D97-AF65-F5344CB8AC3E}">
-        <p14:creationId xmlns:p14="http://schemas.microsoft.com/office/powerpoint/2010/main" val="2108580008"/>
+        <p14:creationId xmlns:p14="http://schemas.microsoft.com/office/powerpoint/2010/main" val="2867342842"/>
       </p:ext>
     </p:extLst>
   </p:cSld>
@@ -1041,6 +1062,13 @@
           </p:nvPr>
         </p:nvSpPr>
         <p:spPr/>
+        <p:txBody>
+          <a:bodyPr/>
+          <a:lstStyle/>
+          <a:p>
+            <a:endParaRPr lang="es-ES" dirty="0"/>
+          </a:p>
+        </p:txBody>
       </p:sp>
       <p:sp>
         <p:nvSpPr>
@@ -1159,6 +1187,13 @@
           </p:nvPr>
         </p:nvSpPr>
         <p:spPr/>
+        <p:txBody>
+          <a:bodyPr/>
+          <a:lstStyle/>
+          <a:p>
+            <a:endParaRPr lang="es-ES" dirty="0"/>
+          </a:p>
+        </p:txBody>
       </p:sp>
       <p:sp>
         <p:nvSpPr>
@@ -1277,6 +1312,13 @@
           </p:nvPr>
         </p:nvSpPr>
         <p:spPr/>
+        <p:txBody>
+          <a:bodyPr/>
+          <a:lstStyle/>
+          <a:p>
+            <a:endParaRPr lang="es-ES" dirty="0"/>
+          </a:p>
+        </p:txBody>
       </p:sp>
       <p:sp>
         <p:nvSpPr>
@@ -1422,7 +1464,7 @@
           <a:p>
             <a:pPr rtl="0"/>
             <a:r>
-              <a:rPr lang="es-ES"/>
+              <a:rPr lang="es-ES" dirty="0"/>
               <a:t>Haga clic para agregar foto</a:t>
             </a:r>
           </a:p>
@@ -1877,7 +1919,7 @@
           <a:p>
             <a:pPr rtl="0"/>
             <a:r>
-              <a:rPr lang="es-ES"/>
+              <a:rPr lang="es-ES" dirty="0"/>
               <a:t>20XX</a:t>
             </a:r>
           </a:p>
@@ -1918,7 +1960,7 @@
           <a:p>
             <a:pPr rtl="0"/>
             <a:r>
-              <a:rPr lang="es-ES"/>
+              <a:rPr lang="es-ES" dirty="0"/>
               <a:t>Presentación de lanzamiento</a:t>
             </a:r>
           </a:p>
@@ -2094,7 +2136,7 @@
           <a:p>
             <a:pPr rtl="0"/>
             <a:r>
-              <a:rPr lang="es-ES"/>
+              <a:rPr lang="es-ES" dirty="0"/>
               <a:t>Haga clic para agregar foto</a:t>
             </a:r>
           </a:p>
@@ -2323,7 +2365,7 @@
           <a:p>
             <a:pPr rtl="0"/>
             <a:r>
-              <a:rPr lang="es-ES"/>
+              <a:rPr lang="es-ES" dirty="0"/>
               <a:t>20XX</a:t>
             </a:r>
           </a:p>
@@ -2371,7 +2413,7 @@
           <a:p>
             <a:pPr rtl="0"/>
             <a:r>
-              <a:rPr lang="es-ES"/>
+              <a:rPr lang="es-ES" dirty="0"/>
               <a:t>Presentación de lanzamiento</a:t>
             </a:r>
           </a:p>
@@ -2685,7 +2727,7 @@
           <a:p>
             <a:pPr rtl="0"/>
             <a:r>
-              <a:rPr lang="es-ES"/>
+              <a:rPr lang="es-ES" dirty="0"/>
               <a:t>20XX</a:t>
             </a:r>
           </a:p>
@@ -2726,7 +2768,7 @@
           <a:p>
             <a:pPr rtl="0"/>
             <a:r>
-              <a:rPr lang="es-ES"/>
+              <a:rPr lang="es-ES" dirty="0"/>
               <a:t>Presentación de lanzamiento</a:t>
             </a:r>
           </a:p>
@@ -2958,7 +3000,7 @@
           <a:p>
             <a:pPr rtl="0"/>
             <a:r>
-              <a:rPr lang="es-ES"/>
+              <a:rPr lang="es-ES" dirty="0"/>
               <a:t>Haga clic para agregar foto</a:t>
             </a:r>
           </a:p>
@@ -3050,7 +3092,7 @@
           <a:p>
             <a:pPr rtl="0"/>
             <a:r>
-              <a:rPr lang="es-ES"/>
+              <a:rPr lang="es-ES" dirty="0"/>
               <a:t>Haga clic para agregar una foto</a:t>
             </a:r>
           </a:p>
@@ -3394,7 +3436,7 @@
           <a:p>
             <a:pPr rtl="0"/>
             <a:r>
-              <a:rPr lang="es-ES"/>
+              <a:rPr lang="es-ES" dirty="0"/>
               <a:t>20XX</a:t>
             </a:r>
           </a:p>
@@ -3443,7 +3485,7 @@
           <a:p>
             <a:pPr rtl="0"/>
             <a:r>
-              <a:rPr lang="es-ES"/>
+              <a:rPr lang="es-ES" dirty="0"/>
               <a:t>Presentación de lanzamiento</a:t>
             </a:r>
           </a:p>
@@ -3578,7 +3620,7 @@
           <a:p>
             <a:pPr rtl="0"/>
             <a:r>
-              <a:rPr lang="es-ES"/>
+              <a:rPr lang="es-ES" dirty="0"/>
               <a:t>Haga clic para agregar foto</a:t>
             </a:r>
           </a:p>
@@ -3826,7 +3868,7 @@
           <a:p>
             <a:pPr rtl="0"/>
             <a:r>
-              <a:rPr lang="es-ES"/>
+              <a:rPr lang="es-ES" dirty="0"/>
               <a:t>Haga clic para agregar foto</a:t>
             </a:r>
           </a:p>
@@ -3867,7 +3909,7 @@
           <a:p>
             <a:pPr rtl="0"/>
             <a:r>
-              <a:rPr lang="es-ES"/>
+              <a:rPr lang="es-ES" dirty="0"/>
               <a:t>20XX</a:t>
             </a:r>
           </a:p>
@@ -3920,7 +3962,7 @@
           <a:p>
             <a:pPr rtl="0"/>
             <a:r>
-              <a:rPr lang="es-ES"/>
+              <a:rPr lang="es-ES" dirty="0"/>
               <a:t>Presentación de lanzamiento</a:t>
             </a:r>
           </a:p>
@@ -4284,7 +4326,7 @@
           <a:p>
             <a:pPr rtl="0"/>
             <a:r>
-              <a:rPr lang="es-ES"/>
+              <a:rPr lang="es-ES" dirty="0"/>
               <a:t>20XX</a:t>
             </a:r>
           </a:p>
@@ -4332,7 +4374,7 @@
           <a:p>
             <a:pPr rtl="0"/>
             <a:r>
-              <a:rPr lang="es-ES"/>
+              <a:rPr lang="es-ES" dirty="0"/>
               <a:t>Presentación de lanzamiento</a:t>
             </a:r>
           </a:p>
@@ -4517,7 +4559,7 @@
           <a:p>
             <a:pPr rtl="0"/>
             <a:r>
-              <a:rPr lang="es-ES"/>
+              <a:rPr lang="es-ES" dirty="0"/>
               <a:t>Haga clic para agregar foto</a:t>
             </a:r>
           </a:p>
@@ -4613,7 +4655,7 @@
           <a:p>
             <a:pPr rtl="0"/>
             <a:r>
-              <a:rPr lang="es-ES"/>
+              <a:rPr lang="es-ES" dirty="0"/>
               <a:t>20XX</a:t>
             </a:r>
           </a:p>
@@ -4666,7 +4708,7 @@
           <a:p>
             <a:pPr rtl="0"/>
             <a:r>
-              <a:rPr lang="es-ES"/>
+              <a:rPr lang="es-ES" dirty="0"/>
               <a:t>Presentación de lanzamiento</a:t>
             </a:r>
           </a:p>
@@ -4842,7 +4884,7 @@
           <a:p>
             <a:pPr rtl="0"/>
             <a:r>
-              <a:rPr lang="es-ES"/>
+              <a:rPr lang="es-ES" dirty="0"/>
               <a:t>Haga clic para agregar foto</a:t>
             </a:r>
           </a:p>
@@ -5148,7 +5190,7 @@
           <a:p>
             <a:pPr rtl="0"/>
             <a:r>
-              <a:rPr lang="es-ES"/>
+              <a:rPr lang="es-ES" dirty="0"/>
               <a:t>20XX</a:t>
             </a:r>
           </a:p>
@@ -5196,7 +5238,7 @@
           <a:p>
             <a:pPr rtl="0"/>
             <a:r>
-              <a:rPr lang="es-ES"/>
+              <a:rPr lang="es-ES" dirty="0"/>
               <a:t>Presentación de lanzamiento</a:t>
             </a:r>
           </a:p>
@@ -5704,7 +5746,7 @@
           <a:p>
             <a:pPr rtl="0"/>
             <a:r>
-              <a:rPr lang="es-ES"/>
+              <a:rPr lang="es-ES" dirty="0"/>
               <a:t>20XX</a:t>
             </a:r>
           </a:p>
@@ -5752,7 +5794,7 @@
           <a:p>
             <a:pPr rtl="0"/>
             <a:r>
-              <a:rPr lang="es-ES"/>
+              <a:rPr lang="es-ES" dirty="0"/>
               <a:t>Presentación de lanzamiento</a:t>
             </a:r>
           </a:p>
@@ -5982,7 +6024,7 @@
           <a:p>
             <a:pPr rtl="0"/>
             <a:r>
-              <a:rPr lang="es-ES"/>
+              <a:rPr lang="es-ES" dirty="0"/>
               <a:t>Haga clic para agregar una foto</a:t>
             </a:r>
           </a:p>
@@ -6034,7 +6076,7 @@
           <a:p>
             <a:pPr rtl="0"/>
             <a:r>
-              <a:rPr lang="es-ES"/>
+              <a:rPr lang="es-ES" dirty="0"/>
               <a:t>20XX</a:t>
             </a:r>
           </a:p>
@@ -6087,7 +6129,7 @@
           <a:p>
             <a:pPr rtl="0"/>
             <a:r>
-              <a:rPr lang="es-ES"/>
+              <a:rPr lang="es-ES" dirty="0"/>
               <a:t>Presentación de lanzamiento</a:t>
             </a:r>
           </a:p>
@@ -6223,7 +6265,7 @@
           <a:p>
             <a:pPr rtl="0"/>
             <a:r>
-              <a:rPr lang="es-ES"/>
+              <a:rPr lang="es-ES" dirty="0"/>
               <a:t>20XX</a:t>
             </a:r>
           </a:p>
@@ -6271,7 +6313,7 @@
           <a:p>
             <a:pPr rtl="0"/>
             <a:r>
-              <a:rPr lang="es-ES"/>
+              <a:rPr lang="es-ES" dirty="0"/>
               <a:t>Presentación de lanzamiento</a:t>
             </a:r>
           </a:p>
@@ -6666,7 +6708,7 @@
         </p:nvPicPr>
         <p:blipFill>
           <a:blip r:embed="rId3">
-            <a:alphaModFix amt="70000"/>
+            <a:alphaModFix amt="50000"/>
           </a:blip>
           <a:srcRect t="14355" b="43992"/>
           <a:stretch>
@@ -6706,7 +6748,7 @@
           </a:xfrm>
           <a:ln>
             <a:solidFill>
-              <a:schemeClr val="tx1"/>
+              <a:srgbClr val="F5FAE8"/>
             </a:solidFill>
           </a:ln>
         </p:spPr>
@@ -6721,9 +6763,7 @@
             <a:r>
               <a:rPr lang="es-ES" dirty="0">
                 <a:solidFill>
-                  <a:schemeClr val="accent1">
-                    <a:lumMod val="10000"/>
-                  </a:schemeClr>
+                  <a:srgbClr val="F5FAE8"/>
                 </a:solidFill>
               </a:rPr>
               <a:t>HUDSON BREW </a:t>
@@ -6731,18 +6771,14 @@
             <a:br>
               <a:rPr lang="es-ES" dirty="0">
                 <a:solidFill>
-                  <a:schemeClr val="accent1">
-                    <a:lumMod val="10000"/>
-                  </a:schemeClr>
+                  <a:srgbClr val="F5FAE8"/>
                 </a:solidFill>
               </a:rPr>
             </a:br>
             <a:r>
               <a:rPr lang="es-ES" sz="1800" dirty="0">
                 <a:solidFill>
-                  <a:schemeClr val="accent1">
-                    <a:lumMod val="10000"/>
-                  </a:schemeClr>
+                  <a:srgbClr val="F5FAE8"/>
                 </a:solidFill>
               </a:rPr>
               <a:t>Análisis Integral de Ventas para la Toma de Decisiones Empresariales</a:t>
@@ -6775,7 +6811,7 @@
           <a:noFill/>
           <a:ln w="38100">
             <a:solidFill>
-              <a:schemeClr val="tx1"/>
+              <a:srgbClr val="F5FAE8"/>
             </a:solidFill>
           </a:ln>
         </p:spPr>
@@ -6836,9 +6872,7 @@
             <a:r>
               <a:rPr lang="es-ES" sz="1400" dirty="0">
                 <a:solidFill>
-                  <a:schemeClr val="accent1">
-                    <a:lumMod val="10000"/>
-                  </a:schemeClr>
+                  <a:srgbClr val="F5FAE8"/>
                 </a:solidFill>
               </a:rPr>
               <a:t>Elías Hernández Barral</a:t>
@@ -6847,62 +6881,24 @@
           <a:p>
             <a:pPr algn="r"/>
             <a:r>
-              <a:rPr lang="es-ES" sz="1400" dirty="0" err="1">
+              <a:rPr lang="es-ES" sz="1400" dirty="0">
                 <a:solidFill>
-                  <a:schemeClr val="accent1">
-                    <a:lumMod val="10000"/>
-                  </a:schemeClr>
+                  <a:srgbClr val="F5FAE8"/>
                 </a:solidFill>
               </a:rPr>
-              <a:t>Bootcamp</a:t>
-            </a:r>
+              <a:t>Bootcamp Data Analytics</a:t>
+            </a:r>
+          </a:p>
+          <a:p>
+            <a:pPr algn="r"/>
             <a:r>
               <a:rPr lang="es-ES" sz="1400" dirty="0">
                 <a:solidFill>
-                  <a:schemeClr val="accent1">
-                    <a:lumMod val="10000"/>
-                  </a:schemeClr>
-                </a:solidFill>
-              </a:rPr>
-              <a:t> Data </a:t>
-            </a:r>
-            <a:r>
-              <a:rPr lang="es-ES" sz="1400" dirty="0" err="1">
-                <a:solidFill>
-                  <a:schemeClr val="accent1">
-                    <a:lumMod val="10000"/>
-                  </a:schemeClr>
-                </a:solidFill>
-              </a:rPr>
-              <a:t>Analytics</a:t>
-            </a:r>
-            <a:endParaRPr lang="es-ES" sz="1400" dirty="0">
-              <a:solidFill>
-                <a:schemeClr val="accent1">
-                  <a:lumMod val="10000"/>
-                </a:schemeClr>
-              </a:solidFill>
-            </a:endParaRPr>
-          </a:p>
-          <a:p>
-            <a:pPr algn="r"/>
-            <a:r>
-              <a:rPr lang="es-ES" sz="1400" dirty="0" err="1">
-                <a:solidFill>
-                  <a:schemeClr val="accent1">
-                    <a:lumMod val="10000"/>
-                  </a:schemeClr>
+                  <a:srgbClr val="F5FAE8"/>
                 </a:solidFill>
               </a:rPr>
               <a:t>Neoland</a:t>
             </a:r>
-            <a:endParaRPr lang="es-ES" sz="1400" dirty="0">
-              <a:solidFill>
-                <a:schemeClr val="accent1">
-                  <a:lumMod val="10000"/>
-                </a:schemeClr>
-              </a:solidFill>
-            </a:endParaRPr>
           </a:p>
           <a:p>
             <a:br>
@@ -7043,41 +7039,37 @@
           </a:p>
           <a:p>
             <a:r>
-              <a:rPr lang="es-ES" sz="1400" dirty="0"/>
+              <a:rPr lang="es-ES" sz="1600" dirty="0"/>
               <a:t>Las ventas crecieron un 103,8 %.</a:t>
             </a:r>
           </a:p>
           <a:p>
             <a:r>
-              <a:rPr lang="es-ES" sz="1400" dirty="0"/>
+              <a:rPr lang="es-ES" sz="1600" dirty="0"/>
               <a:t>Coffee es la principal fuente de ingresos.</a:t>
             </a:r>
           </a:p>
           <a:p>
             <a:r>
-              <a:rPr lang="es-ES" sz="1400" dirty="0" err="1"/>
-              <a:t>Hell's</a:t>
-            </a:r>
-            <a:r>
-              <a:rPr lang="es-ES" sz="1400" dirty="0"/>
-              <a:t> Kitchen presenta el mejor rendimiento.</a:t>
-            </a:r>
-          </a:p>
-          <a:p>
-            <a:r>
-              <a:rPr lang="es-ES" sz="1400" dirty="0"/>
+              <a:rPr lang="es-ES" sz="1600" dirty="0"/>
+              <a:t>Hell's Kitchen presenta el mejor rendimiento.</a:t>
+            </a:r>
+          </a:p>
+          <a:p>
+            <a:r>
+              <a:rPr lang="es-ES" sz="1600" dirty="0"/>
               <a:t>La actividad se concentra entre las 07:00 y las 10:00.</a:t>
             </a:r>
           </a:p>
           <a:p>
             <a:r>
-              <a:rPr lang="es-ES" sz="1400" dirty="0"/>
+              <a:rPr lang="es-ES" sz="1600" dirty="0"/>
               <a:t>Existen patrones diferenciados de consumo.</a:t>
             </a:r>
           </a:p>
           <a:p>
             <a:r>
-              <a:rPr lang="es-ES" sz="1400" dirty="0"/>
+              <a:rPr lang="es-ES" sz="1600" dirty="0"/>
               <a:t>Los resultados respaldan una posible expansión del negocio.</a:t>
             </a:r>
           </a:p>
@@ -7247,6 +7239,16 @@
           <a:p>
             <a:r>
               <a:rPr lang="es-ES" sz="1400" dirty="0"/>
+              <a:t>Mantener acciones sobre la franja estable de 11:00 a 17:00</a:t>
+            </a:r>
+            <a:r>
+              <a:rPr lang="es-ES" sz="1600" dirty="0"/>
+              <a:t>.</a:t>
+            </a:r>
+          </a:p>
+          <a:p>
+            <a:r>
+              <a:rPr lang="es-ES" sz="1400" dirty="0"/>
               <a:t>Potenciar la categoría Coffee.</a:t>
             </a:r>
           </a:p>
@@ -7259,25 +7261,7 @@
           <a:p>
             <a:r>
               <a:rPr lang="es-ES" sz="1400" dirty="0"/>
-              <a:t>Replicar prácticas exitosas de </a:t>
-            </a:r>
-            <a:r>
-              <a:rPr lang="es-ES" sz="1400" dirty="0" err="1"/>
-              <a:t>Hell's</a:t>
-            </a:r>
-            <a:r>
-              <a:rPr lang="es-ES" sz="1400" dirty="0"/>
-              <a:t> Kitchen.</a:t>
-            </a:r>
-          </a:p>
-          <a:p>
-            <a:r>
-              <a:rPr lang="es-ES" sz="1400" dirty="0"/>
-              <a:t>Mantener acciones sobre la franja estable de 11:00 a 17:00</a:t>
-            </a:r>
-            <a:r>
-              <a:rPr lang="es-ES" sz="1600" dirty="0"/>
-              <a:t>.</a:t>
+              <a:t>Replicar prácticas exitosas de Hell's Kitchen.</a:t>
             </a:r>
           </a:p>
           <a:p>
@@ -7396,7 +7380,7 @@
         </p:nvPicPr>
         <p:blipFill>
           <a:blip r:embed="rId3">
-            <a:alphaModFix amt="70000"/>
+            <a:alphaModFix amt="50000"/>
           </a:blip>
           <a:srcRect t="55570" b="2777"/>
           <a:stretch>
@@ -7411,6 +7395,11 @@
           <a:prstGeom prst="rect">
             <a:avLst/>
           </a:prstGeom>
+          <a:ln>
+            <a:solidFill>
+              <a:srgbClr val="F5FAE8"/>
+            </a:solidFill>
+          </a:ln>
         </p:spPr>
       </p:pic>
       <p:sp>
@@ -7436,7 +7425,7 @@
           </a:xfrm>
           <a:ln>
             <a:solidFill>
-              <a:schemeClr val="tx1"/>
+              <a:srgbClr val="F5FAE8"/>
             </a:solidFill>
           </a:ln>
         </p:spPr>
@@ -7451,9 +7440,7 @@
             <a:r>
               <a:rPr lang="es-ES" dirty="0">
                 <a:solidFill>
-                  <a:schemeClr val="accent1">
-                    <a:lumMod val="10000"/>
-                  </a:schemeClr>
+                  <a:srgbClr val="F5FAE8"/>
                 </a:solidFill>
               </a:rPr>
               <a:t>Muchas gracias</a:t>
@@ -7491,184 +7478,6 @@
 </file>
 
 <file path=ppt/slides/slide2.xml><?xml version="1.0" encoding="utf-8"?>
-<p:sld xmlns:a="http://schemas.openxmlformats.org/drawingml/2006/main" xmlns:r="http://schemas.openxmlformats.org/officeDocument/2006/relationships" xmlns:p="http://schemas.openxmlformats.org/presentationml/2006/main">
-  <p:cSld>
-    <p:spTree>
-      <p:nvGrpSpPr>
-        <p:cNvPr id="1" name=""/>
-        <p:cNvGrpSpPr/>
-        <p:nvPr/>
-      </p:nvGrpSpPr>
-      <p:grpSpPr>
-        <a:xfrm>
-          <a:off x="0" y="0"/>
-          <a:ext cx="0" cy="0"/>
-          <a:chOff x="0" y="0"/>
-          <a:chExt cx="0" cy="0"/>
-        </a:xfrm>
-      </p:grpSpPr>
-      <p:sp>
-        <p:nvSpPr>
-          <p:cNvPr id="26" name="Título 25">
-            <a:extLst>
-              <a:ext uri="{FF2B5EF4-FFF2-40B4-BE49-F238E27FC236}">
-                <a16:creationId xmlns:a16="http://schemas.microsoft.com/office/drawing/2014/main" id="{CDA2767E-38F3-49F7-BE02-EA3E6C7C8096}"/>
-              </a:ext>
-            </a:extLst>
-          </p:cNvPr>
-          <p:cNvSpPr>
-            <a:spLocks noGrp="1"/>
-          </p:cNvSpPr>
-          <p:nvPr>
-            <p:ph type="title"/>
-          </p:nvPr>
-        </p:nvSpPr>
-        <p:spPr>
-          <a:xfrm>
-            <a:off x="636608" y="804862"/>
-            <a:ext cx="3401992" cy="5121375"/>
-          </a:xfrm>
-          <a:ln>
-            <a:noFill/>
-          </a:ln>
-        </p:spPr>
-        <p:txBody>
-          <a:bodyPr rtlCol="0"/>
-          <a:lstStyle>
-            <a:defPPr>
-              <a:defRPr lang="es-ES"/>
-            </a:defPPr>
-          </a:lstStyle>
-          <a:p>
-            <a:r>
-              <a:rPr lang="es-ES" dirty="0"/>
-              <a:t>Contexto del Proyecto</a:t>
-            </a:r>
-          </a:p>
-        </p:txBody>
-      </p:sp>
-      <p:sp>
-        <p:nvSpPr>
-          <p:cNvPr id="50" name="Marcador de texto 17">
-            <a:extLst>
-              <a:ext uri="{FF2B5EF4-FFF2-40B4-BE49-F238E27FC236}">
-                <a16:creationId xmlns:a16="http://schemas.microsoft.com/office/drawing/2014/main" id="{62192F0C-65C9-4E6D-9314-81FB7E4DB469}"/>
-              </a:ext>
-            </a:extLst>
-          </p:cNvPr>
-          <p:cNvSpPr>
-            <a:spLocks noGrp="1"/>
-          </p:cNvSpPr>
-          <p:nvPr>
-            <p:ph sz="quarter" idx="10"/>
-          </p:nvPr>
-        </p:nvSpPr>
-        <p:spPr>
-          <a:xfrm>
-            <a:off x="5579338" y="804863"/>
-            <a:ext cx="5716587" cy="5248276"/>
-          </a:xfrm>
-        </p:spPr>
-        <p:txBody>
-          <a:bodyPr rtlCol="0" anchor="ctr"/>
-          <a:lstStyle>
-            <a:defPPr>
-              <a:defRPr lang="es-ES"/>
-            </a:defPPr>
-          </a:lstStyle>
-          <a:p>
-            <a:r>
-              <a:rPr lang="es-ES" sz="1600" dirty="0"/>
-              <a:t>Hudson Brew es una franquicia ficticia de cafeterías que necesitaba comprender mejor el comportamiento de sus ventas para optimizar su gestión y evaluar futuras oportunidades de crecimiento.</a:t>
-            </a:r>
-          </a:p>
-          <a:p>
-            <a:r>
-              <a:rPr lang="es-ES" sz="1600" dirty="0"/>
-              <a:t>Para ello se desarrolló un proyecto completo de analítica de datos utilizando:</a:t>
-            </a:r>
-          </a:p>
-          <a:p>
-            <a:r>
-              <a:rPr lang="es-ES" sz="1600" dirty="0"/>
-              <a:t>PostgreSQL</a:t>
-            </a:r>
-          </a:p>
-          <a:p>
-            <a:r>
-              <a:rPr lang="es-ES" sz="1600" dirty="0"/>
-              <a:t>Python</a:t>
-            </a:r>
-          </a:p>
-          <a:p>
-            <a:r>
-              <a:rPr lang="es-ES" sz="1600" dirty="0"/>
-              <a:t>Power BI</a:t>
-            </a:r>
-          </a:p>
-          <a:p>
-            <a:r>
-              <a:rPr lang="es-ES" sz="1600" dirty="0"/>
-              <a:t>Machine Learning</a:t>
-            </a:r>
-          </a:p>
-          <a:p>
-            <a:r>
-              <a:rPr lang="es-ES" sz="1600" dirty="0"/>
-              <a:t>El objetivo fue transformar datos en información útil para la toma de decisiones.</a:t>
-            </a:r>
-          </a:p>
-        </p:txBody>
-      </p:sp>
-      <p:sp>
-        <p:nvSpPr>
-          <p:cNvPr id="2" name="Marcador de número de diapositiva 1">
-            <a:extLst>
-              <a:ext uri="{FF2B5EF4-FFF2-40B4-BE49-F238E27FC236}">
-                <a16:creationId xmlns:a16="http://schemas.microsoft.com/office/drawing/2014/main" id="{00490171-2859-5322-0F76-C05597544FBD}"/>
-              </a:ext>
-            </a:extLst>
-          </p:cNvPr>
-          <p:cNvSpPr>
-            <a:spLocks noGrp="1"/>
-          </p:cNvSpPr>
-          <p:nvPr>
-            <p:ph type="sldNum" sz="quarter" idx="4"/>
-          </p:nvPr>
-        </p:nvSpPr>
-        <p:spPr/>
-        <p:txBody>
-          <a:bodyPr rtlCol="0"/>
-          <a:lstStyle>
-            <a:defPPr>
-              <a:defRPr lang="es-ES"/>
-            </a:defPPr>
-          </a:lstStyle>
-          <a:p>
-            <a:pPr rtl="0"/>
-            <a:fld id="{EA87306C-81BA-4795-A5CA-9392456A8C1E}" type="slidenum">
-              <a:rPr lang="es-ES" smtClean="0"/>
-              <a:pPr rtl="0"/>
-              <a:t>2</a:t>
-            </a:fld>
-            <a:endParaRPr lang="es-ES" dirty="0"/>
-          </a:p>
-        </p:txBody>
-      </p:sp>
-    </p:spTree>
-    <p:extLst>
-      <p:ext uri="{BB962C8B-B14F-4D97-AF65-F5344CB8AC3E}">
-        <p14:creationId xmlns:p14="http://schemas.microsoft.com/office/powerpoint/2010/main" val="654652765"/>
-      </p:ext>
-    </p:extLst>
-  </p:cSld>
-  <p:clrMapOvr>
-    <a:masterClrMapping/>
-  </p:clrMapOvr>
-</p:sld>
-</file>
-
-<file path=ppt/slides/slide3.xml><?xml version="1.0" encoding="utf-8"?>
 <p:sld xmlns:a="http://schemas.openxmlformats.org/drawingml/2006/main" xmlns:r="http://schemas.openxmlformats.org/officeDocument/2006/relationships" xmlns:p="http://schemas.openxmlformats.org/presentationml/2006/main">
   <p:cSld>
     <p:spTree>
@@ -7766,15 +7575,185 @@
             </a:pPr>
             <a:r>
               <a:rPr lang="es-ES" sz="1600" dirty="0"/>
-              <a:t>Analizar el rendimiento comercial de Hudson Brew mediante técnicas de Business </a:t>
-            </a:r>
-            <a:r>
-              <a:rPr lang="es-ES" sz="1600" dirty="0" err="1"/>
-              <a:t>Intelligence</a:t>
-            </a:r>
+              <a:t>Analizar el rendimiento comercial de Hudson Brew mediante técnicas de Business Intelligence y Machine Learning para identificar patrones de consumo, oportunidades de mejora y evidencias que apoyen la toma de decisiones estratégicas.</a:t>
+            </a:r>
+          </a:p>
+        </p:txBody>
+      </p:sp>
+      <p:sp>
+        <p:nvSpPr>
+          <p:cNvPr id="2" name="Marcador de número de diapositiva 1">
+            <a:extLst>
+              <a:ext uri="{FF2B5EF4-FFF2-40B4-BE49-F238E27FC236}">
+                <a16:creationId xmlns:a16="http://schemas.microsoft.com/office/drawing/2014/main" id="{1DACC63D-F49B-8FE5-B76C-1A0E8C73FB4C}"/>
+              </a:ext>
+            </a:extLst>
+          </p:cNvPr>
+          <p:cNvSpPr>
+            <a:spLocks noGrp="1"/>
+          </p:cNvSpPr>
+          <p:nvPr>
+            <p:ph type="sldNum" sz="quarter" idx="4"/>
+          </p:nvPr>
+        </p:nvSpPr>
+        <p:spPr/>
+        <p:txBody>
+          <a:bodyPr rtlCol="0"/>
+          <a:lstStyle>
+            <a:defPPr>
+              <a:defRPr lang="es-ES"/>
+            </a:defPPr>
+          </a:lstStyle>
+          <a:p>
+            <a:pPr rtl="0"/>
+            <a:fld id="{EA87306C-81BA-4795-A5CA-9392456A8C1E}" type="slidenum">
+              <a:rPr lang="es-ES" smtClean="0"/>
+              <a:pPr rtl="0"/>
+              <a:t>2</a:t>
+            </a:fld>
+            <a:endParaRPr lang="es-ES" dirty="0"/>
+          </a:p>
+        </p:txBody>
+      </p:sp>
+    </p:spTree>
+    <p:extLst>
+      <p:ext uri="{BB962C8B-B14F-4D97-AF65-F5344CB8AC3E}">
+        <p14:creationId xmlns:p14="http://schemas.microsoft.com/office/powerpoint/2010/main" val="2115261234"/>
+      </p:ext>
+    </p:extLst>
+  </p:cSld>
+  <p:clrMapOvr>
+    <a:masterClrMapping/>
+  </p:clrMapOvr>
+</p:sld>
+</file>
+
+<file path=ppt/slides/slide3.xml><?xml version="1.0" encoding="utf-8"?>
+<p:sld xmlns:a="http://schemas.openxmlformats.org/drawingml/2006/main" xmlns:r="http://schemas.openxmlformats.org/officeDocument/2006/relationships" xmlns:p="http://schemas.openxmlformats.org/presentationml/2006/main">
+  <p:cSld>
+    <p:spTree>
+      <p:nvGrpSpPr>
+        <p:cNvPr id="1" name=""/>
+        <p:cNvGrpSpPr/>
+        <p:nvPr/>
+      </p:nvGrpSpPr>
+      <p:grpSpPr>
+        <a:xfrm>
+          <a:off x="0" y="0"/>
+          <a:ext cx="0" cy="0"/>
+          <a:chOff x="0" y="0"/>
+          <a:chExt cx="0" cy="0"/>
+        </a:xfrm>
+      </p:grpSpPr>
+      <p:sp>
+        <p:nvSpPr>
+          <p:cNvPr id="26" name="Título 25">
+            <a:extLst>
+              <a:ext uri="{FF2B5EF4-FFF2-40B4-BE49-F238E27FC236}">
+                <a16:creationId xmlns:a16="http://schemas.microsoft.com/office/drawing/2014/main" id="{CDA2767E-38F3-49F7-BE02-EA3E6C7C8096}"/>
+              </a:ext>
+            </a:extLst>
+          </p:cNvPr>
+          <p:cNvSpPr>
+            <a:spLocks noGrp="1"/>
+          </p:cNvSpPr>
+          <p:nvPr>
+            <p:ph type="title"/>
+          </p:nvPr>
+        </p:nvSpPr>
+        <p:spPr>
+          <a:xfrm>
+            <a:off x="636608" y="804862"/>
+            <a:ext cx="3401992" cy="5121375"/>
+          </a:xfrm>
+          <a:ln>
+            <a:noFill/>
+          </a:ln>
+        </p:spPr>
+        <p:txBody>
+          <a:bodyPr rtlCol="0"/>
+          <a:lstStyle>
+            <a:defPPr>
+              <a:defRPr lang="es-ES"/>
+            </a:defPPr>
+          </a:lstStyle>
+          <a:p>
+            <a:r>
+              <a:rPr lang="es-ES" dirty="0"/>
+              <a:t>Contexto del Proyecto</a:t>
+            </a:r>
+          </a:p>
+        </p:txBody>
+      </p:sp>
+      <p:sp>
+        <p:nvSpPr>
+          <p:cNvPr id="50" name="Marcador de texto 17">
+            <a:extLst>
+              <a:ext uri="{FF2B5EF4-FFF2-40B4-BE49-F238E27FC236}">
+                <a16:creationId xmlns:a16="http://schemas.microsoft.com/office/drawing/2014/main" id="{62192F0C-65C9-4E6D-9314-81FB7E4DB469}"/>
+              </a:ext>
+            </a:extLst>
+          </p:cNvPr>
+          <p:cNvSpPr>
+            <a:spLocks noGrp="1"/>
+          </p:cNvSpPr>
+          <p:nvPr>
+            <p:ph sz="quarter" idx="10"/>
+          </p:nvPr>
+        </p:nvSpPr>
+        <p:spPr>
+          <a:xfrm>
+            <a:off x="5579338" y="804863"/>
+            <a:ext cx="5716587" cy="5248276"/>
+          </a:xfrm>
+        </p:spPr>
+        <p:txBody>
+          <a:bodyPr rtlCol="0" anchor="ctr"/>
+          <a:lstStyle>
+            <a:defPPr>
+              <a:defRPr lang="es-ES"/>
+            </a:defPPr>
+          </a:lstStyle>
+          <a:p>
             <a:r>
               <a:rPr lang="es-ES" sz="1600" dirty="0"/>
-              <a:t> y Machine Learning para identificar patrones de consumo, oportunidades de mejora y evidencias que apoyen la toma de decisiones estratégicas.</a:t>
+              <a:t>Hudson Brew es una franquicia ficticia de cafeterías que necesitaba comprender mejor el comportamiento de sus ventas para optimizar su gestión y evaluar futuras oportunidades de crecimiento.</a:t>
+            </a:r>
+          </a:p>
+          <a:p>
+            <a:r>
+              <a:rPr lang="es-ES" sz="1600" dirty="0"/>
+              <a:t>Para ello se desarrolló un proyecto completo de analítica de datos utilizando:</a:t>
+            </a:r>
+          </a:p>
+          <a:p>
+            <a:r>
+              <a:rPr lang="es-ES" sz="1600" dirty="0"/>
+              <a:t>PostgreSQL</a:t>
+            </a:r>
+          </a:p>
+          <a:p>
+            <a:r>
+              <a:rPr lang="es-ES" sz="1600" dirty="0"/>
+              <a:t>Python</a:t>
+            </a:r>
+          </a:p>
+          <a:p>
+            <a:r>
+              <a:rPr lang="es-ES" sz="1600" dirty="0"/>
+              <a:t>Power BI</a:t>
+            </a:r>
+          </a:p>
+          <a:p>
+            <a:r>
+              <a:rPr lang="es-ES" sz="1600" dirty="0"/>
+              <a:t>Machine Learning</a:t>
+            </a:r>
+          </a:p>
+          <a:p>
+            <a:r>
+              <a:rPr lang="es-ES" sz="1600" dirty="0"/>
+              <a:t>El objetivo fue transformar datos en información útil para la toma de decisiones.</a:t>
             </a:r>
           </a:p>
         </p:txBody>
@@ -7784,7 +7763,7 @@
           <p:cNvPr id="2" name="Marcador de número de diapositiva 1">
             <a:extLst>
               <a:ext uri="{FF2B5EF4-FFF2-40B4-BE49-F238E27FC236}">
-                <a16:creationId xmlns:a16="http://schemas.microsoft.com/office/drawing/2014/main" id="{1DACC63D-F49B-8FE5-B76C-1A0E8C73FB4C}"/>
+                <a16:creationId xmlns:a16="http://schemas.microsoft.com/office/drawing/2014/main" id="{00490171-2859-5322-0F76-C05597544FBD}"/>
               </a:ext>
             </a:extLst>
           </p:cNvPr>
@@ -7817,7 +7796,7 @@
     </p:spTree>
     <p:extLst>
       <p:ext uri="{BB962C8B-B14F-4D97-AF65-F5344CB8AC3E}">
-        <p14:creationId xmlns:p14="http://schemas.microsoft.com/office/powerpoint/2010/main" val="2115261234"/>
+        <p14:creationId xmlns:p14="http://schemas.microsoft.com/office/powerpoint/2010/main" val="654652765"/>
       </p:ext>
     </p:extLst>
   </p:cSld>
@@ -8213,8 +8192,8 @@
         </p:blipFill>
         <p:spPr bwMode="auto">
           <a:xfrm>
-            <a:off x="5241760" y="3084646"/>
-            <a:ext cx="6223482" cy="3355926"/>
+            <a:off x="5386139" y="3255023"/>
+            <a:ext cx="5967662" cy="3217979"/>
           </a:xfrm>
           <a:prstGeom prst="rect">
             <a:avLst/>
@@ -8409,7 +8388,7 @@
         </p:blipFill>
         <p:spPr bwMode="auto">
           <a:xfrm>
-            <a:off x="5407866" y="3104147"/>
+            <a:off x="5407866" y="3116022"/>
             <a:ext cx="6147526" cy="3350544"/>
           </a:xfrm>
           <a:prstGeom prst="rect">
@@ -8532,23 +8511,7 @@
                   <a:schemeClr val="bg1"/>
                 </a:solidFill>
               </a:rPr>
-              <a:t>🏆 </a:t>
-            </a:r>
-            <a:r>
-              <a:rPr lang="es-ES" sz="1400" dirty="0" err="1">
-                <a:solidFill>
-                  <a:schemeClr val="bg1"/>
-                </a:solidFill>
-              </a:rPr>
-              <a:t>Hell's</a:t>
-            </a:r>
-            <a:r>
-              <a:rPr lang="es-ES" sz="1400" dirty="0">
-                <a:solidFill>
-                  <a:schemeClr val="bg1"/>
-                </a:solidFill>
-              </a:rPr>
-              <a:t> Kitchen</a:t>
+              <a:t>🏆 Hell's Kitchen</a:t>
             </a:r>
           </a:p>
           <a:p>
@@ -9434,6 +9397,44 @@
           </a:prstGeom>
         </p:spPr>
       </p:pic>
+      <p:sp>
+        <p:nvSpPr>
+          <p:cNvPr id="5" name="CuadroTexto 4">
+            <a:extLst>
+              <a:ext uri="{FF2B5EF4-FFF2-40B4-BE49-F238E27FC236}">
+                <a16:creationId xmlns:a16="http://schemas.microsoft.com/office/drawing/2014/main" id="{681B047C-A4F9-D4F7-DB6B-F7C2ED35756D}"/>
+              </a:ext>
+            </a:extLst>
+          </p:cNvPr>
+          <p:cNvSpPr txBox="1"/>
+          <p:nvPr/>
+        </p:nvSpPr>
+        <p:spPr>
+          <a:xfrm>
+            <a:off x="10676561" y="5137091"/>
+            <a:ext cx="1080012" cy="369332"/>
+          </a:xfrm>
+          <a:prstGeom prst="rect">
+            <a:avLst/>
+          </a:prstGeom>
+          <a:noFill/>
+        </p:spPr>
+        <p:txBody>
+          <a:bodyPr wrap="square" rtlCol="0">
+            <a:spAutoFit/>
+          </a:bodyPr>
+          <a:lstStyle/>
+          <a:p>
+            <a:r>
+              <a:rPr lang="es-ES" dirty="0">
+                <a:hlinkClick r:id="rId3"/>
+              </a:rPr>
+              <a:t>Power BI</a:t>
+            </a:r>
+            <a:endParaRPr lang="es-ES" dirty="0"/>
+          </a:p>
+        </p:txBody>
+      </p:sp>
     </p:spTree>
     <p:extLst>
       <p:ext uri="{BB962C8B-B14F-4D97-AF65-F5344CB8AC3E}">
@@ -10239,12 +10240,23 @@
 </file>
 
 <file path=customXml/item1.xml><?xml version="1.0" encoding="utf-8"?>
-<?mso-contentType ?>
-<FormTemplates xmlns="http://schemas.microsoft.com/sharepoint/v3/contenttype/forms">
-  <Display>DocumentLibraryForm</Display>
-  <Edit>DocumentLibraryForm</Edit>
-  <New>DocumentLibraryForm</New>
-</FormTemplates>
+<p:properties xmlns:p="http://schemas.microsoft.com/office/2006/metadata/properties" xmlns:xsi="http://www.w3.org/2001/XMLSchema-instance" xmlns:pc="http://schemas.microsoft.com/office/infopath/2007/PartnerControls">
+  <documentManagement>
+    <_ip_UnifiedCompliancePolicyUIAction xmlns="http://schemas.microsoft.com/sharepoint/v3" xsi:nil="true"/>
+    <Image xmlns="71af3243-3dd4-4a8d-8c0d-dd76da1f02a5">
+      <Url xsi:nil="true"/>
+      <Description xsi:nil="true"/>
+    </Image>
+    <Status xmlns="71af3243-3dd4-4a8d-8c0d-dd76da1f02a5">Not started</Status>
+    <Background xmlns="71af3243-3dd4-4a8d-8c0d-dd76da1f02a5">false</Background>
+    <_ip_UnifiedCompliancePolicyProperties xmlns="http://schemas.microsoft.com/sharepoint/v3" xsi:nil="true"/>
+    <ImageTagsTaxHTField xmlns="71af3243-3dd4-4a8d-8c0d-dd76da1f02a5">
+      <Terms xmlns="http://schemas.microsoft.com/office/infopath/2007/PartnerControls"/>
+    </ImageTagsTaxHTField>
+    <TaxCatchAll xmlns="230e9df3-be65-4c73-a93b-d1236ebd677e" xsi:nil="true"/>
+    <MediaServiceKeyPoints xmlns="71af3243-3dd4-4a8d-8c0d-dd76da1f02a5" xsi:nil="true"/>
+  </documentManagement>
+</p:properties>
 </file>
 
 <file path=customXml/item2.xml><?xml version="1.0" encoding="utf-8"?>
@@ -10560,29 +10572,22 @@
 </file>
 
 <file path=customXml/item3.xml><?xml version="1.0" encoding="utf-8"?>
-<p:properties xmlns:p="http://schemas.microsoft.com/office/2006/metadata/properties" xmlns:xsi="http://www.w3.org/2001/XMLSchema-instance" xmlns:pc="http://schemas.microsoft.com/office/infopath/2007/PartnerControls">
-  <documentManagement>
-    <_ip_UnifiedCompliancePolicyUIAction xmlns="http://schemas.microsoft.com/sharepoint/v3" xsi:nil="true"/>
-    <Image xmlns="71af3243-3dd4-4a8d-8c0d-dd76da1f02a5">
-      <Url xsi:nil="true"/>
-      <Description xsi:nil="true"/>
-    </Image>
-    <Status xmlns="71af3243-3dd4-4a8d-8c0d-dd76da1f02a5">Not started</Status>
-    <Background xmlns="71af3243-3dd4-4a8d-8c0d-dd76da1f02a5">false</Background>
-    <_ip_UnifiedCompliancePolicyProperties xmlns="http://schemas.microsoft.com/sharepoint/v3" xsi:nil="true"/>
-    <ImageTagsTaxHTField xmlns="71af3243-3dd4-4a8d-8c0d-dd76da1f02a5">
-      <Terms xmlns="http://schemas.microsoft.com/office/infopath/2007/PartnerControls"/>
-    </ImageTagsTaxHTField>
-    <TaxCatchAll xmlns="230e9df3-be65-4c73-a93b-d1236ebd677e" xsi:nil="true"/>
-    <MediaServiceKeyPoints xmlns="71af3243-3dd4-4a8d-8c0d-dd76da1f02a5" xsi:nil="true"/>
-  </documentManagement>
-</p:properties>
+<?mso-contentType ?>
+<FormTemplates xmlns="http://schemas.microsoft.com/sharepoint/v3/contenttype/forms">
+  <Display>DocumentLibraryForm</Display>
+  <Edit>DocumentLibraryForm</Edit>
+  <New>DocumentLibraryForm</New>
+</FormTemplates>
 </file>
 
 <file path=customXml/itemProps1.xml><?xml version="1.0" encoding="utf-8"?>
-<ds:datastoreItem xmlns:ds="http://schemas.openxmlformats.org/officeDocument/2006/customXml" ds:itemID="{E9424615-5FE5-4F43-AE24-3BC9A0532687}">
+<ds:datastoreItem xmlns:ds="http://schemas.openxmlformats.org/officeDocument/2006/customXml" ds:itemID="{AF19A644-6410-4EC7-894C-877E70305DFF}">
   <ds:schemaRefs>
-    <ds:schemaRef ds:uri="http://schemas.microsoft.com/sharepoint/v3/contenttype/forms"/>
+    <ds:schemaRef ds:uri="http://schemas.microsoft.com/office/2006/metadata/properties"/>
+    <ds:schemaRef ds:uri="http://schemas.microsoft.com/office/infopath/2007/PartnerControls"/>
+    <ds:schemaRef ds:uri="http://schemas.microsoft.com/sharepoint/v3"/>
+    <ds:schemaRef ds:uri="71af3243-3dd4-4a8d-8c0d-dd76da1f02a5"/>
+    <ds:schemaRef ds:uri="230e9df3-be65-4c73-a93b-d1236ebd677e"/>
   </ds:schemaRefs>
 </ds:datastoreItem>
 </file>
@@ -10609,13 +10614,9 @@
 </file>
 
 <file path=customXml/itemProps3.xml><?xml version="1.0" encoding="utf-8"?>
-<ds:datastoreItem xmlns:ds="http://schemas.openxmlformats.org/officeDocument/2006/customXml" ds:itemID="{AF19A644-6410-4EC7-894C-877E70305DFF}">
+<ds:datastoreItem xmlns:ds="http://schemas.openxmlformats.org/officeDocument/2006/customXml" ds:itemID="{E9424615-5FE5-4F43-AE24-3BC9A0532687}">
   <ds:schemaRefs>
-    <ds:schemaRef ds:uri="http://schemas.microsoft.com/office/2006/metadata/properties"/>
-    <ds:schemaRef ds:uri="http://schemas.microsoft.com/office/infopath/2007/PartnerControls"/>
-    <ds:schemaRef ds:uri="http://schemas.microsoft.com/sharepoint/v3"/>
-    <ds:schemaRef ds:uri="71af3243-3dd4-4a8d-8c0d-dd76da1f02a5"/>
-    <ds:schemaRef ds:uri="230e9df3-be65-4c73-a93b-d1236ebd677e"/>
+    <ds:schemaRef ds:uri="http://schemas.microsoft.com/sharepoint/v3/contenttype/forms"/>
   </ds:schemaRefs>
 </ds:datastoreItem>
 </file>

</xml_diff>

<commit_message>
cambio de nombre de proyecto y repositorio
</commit_message>
<xml_diff>
--- a/Presentación/Presentación.pptx
+++ b/Presentación/Presentación.pptx
@@ -7575,7 +7575,7 @@
             </a:pPr>
             <a:r>
               <a:rPr lang="es-ES" sz="1600" dirty="0"/>
-              <a:t>Analizar el rendimiento comercial de Hudson Brew mediante técnicas de Business Intelligence y Machine Learning para identificar patrones de consumo, oportunidades de mejora y evidencias que apoyen la toma de decisiones estratégicas.</a:t>
+              <a:t>Analizar el rendimiento comercial de Hudson Brew mediante técnicas de Machine Learning para identificar patrones de consumo, oportunidades de mejora y evidencias que apoyen la toma de decisiones estratégicas.</a:t>
             </a:r>
           </a:p>
         </p:txBody>
@@ -8884,7 +8884,23 @@
                   <a:schemeClr val="bg1"/>
                 </a:solidFill>
               </a:rPr>
-              <a:t>Predecir el importe de las ventas.</a:t>
+              <a:t>Predecir el comportamiento </a:t>
+            </a:r>
+            <a:r>
+              <a:rPr lang="es-ES" sz="1400">
+                <a:solidFill>
+                  <a:schemeClr val="bg1"/>
+                </a:solidFill>
+              </a:rPr>
+              <a:t>de las ventas</a:t>
+            </a:r>
+            <a:r>
+              <a:rPr lang="es-ES" sz="1400" dirty="0">
+                <a:solidFill>
+                  <a:schemeClr val="bg1"/>
+                </a:solidFill>
+              </a:rPr>
+              <a:t>.</a:t>
             </a:r>
           </a:p>
           <a:p>
@@ -10240,23 +10256,12 @@
 </file>
 
 <file path=customXml/item1.xml><?xml version="1.0" encoding="utf-8"?>
-<p:properties xmlns:p="http://schemas.microsoft.com/office/2006/metadata/properties" xmlns:xsi="http://www.w3.org/2001/XMLSchema-instance" xmlns:pc="http://schemas.microsoft.com/office/infopath/2007/PartnerControls">
-  <documentManagement>
-    <_ip_UnifiedCompliancePolicyUIAction xmlns="http://schemas.microsoft.com/sharepoint/v3" xsi:nil="true"/>
-    <Image xmlns="71af3243-3dd4-4a8d-8c0d-dd76da1f02a5">
-      <Url xsi:nil="true"/>
-      <Description xsi:nil="true"/>
-    </Image>
-    <Status xmlns="71af3243-3dd4-4a8d-8c0d-dd76da1f02a5">Not started</Status>
-    <Background xmlns="71af3243-3dd4-4a8d-8c0d-dd76da1f02a5">false</Background>
-    <_ip_UnifiedCompliancePolicyProperties xmlns="http://schemas.microsoft.com/sharepoint/v3" xsi:nil="true"/>
-    <ImageTagsTaxHTField xmlns="71af3243-3dd4-4a8d-8c0d-dd76da1f02a5">
-      <Terms xmlns="http://schemas.microsoft.com/office/infopath/2007/PartnerControls"/>
-    </ImageTagsTaxHTField>
-    <TaxCatchAll xmlns="230e9df3-be65-4c73-a93b-d1236ebd677e" xsi:nil="true"/>
-    <MediaServiceKeyPoints xmlns="71af3243-3dd4-4a8d-8c0d-dd76da1f02a5" xsi:nil="true"/>
-  </documentManagement>
-</p:properties>
+<?mso-contentType ?>
+<FormTemplates xmlns="http://schemas.microsoft.com/sharepoint/v3/contenttype/forms">
+  <Display>DocumentLibraryForm</Display>
+  <Edit>DocumentLibraryForm</Edit>
+  <New>DocumentLibraryForm</New>
+</FormTemplates>
 </file>
 
 <file path=customXml/item2.xml><?xml version="1.0" encoding="utf-8"?>
@@ -10572,22 +10577,29 @@
 </file>
 
 <file path=customXml/item3.xml><?xml version="1.0" encoding="utf-8"?>
-<?mso-contentType ?>
-<FormTemplates xmlns="http://schemas.microsoft.com/sharepoint/v3/contenttype/forms">
-  <Display>DocumentLibraryForm</Display>
-  <Edit>DocumentLibraryForm</Edit>
-  <New>DocumentLibraryForm</New>
-</FormTemplates>
+<p:properties xmlns:p="http://schemas.microsoft.com/office/2006/metadata/properties" xmlns:xsi="http://www.w3.org/2001/XMLSchema-instance" xmlns:pc="http://schemas.microsoft.com/office/infopath/2007/PartnerControls">
+  <documentManagement>
+    <_ip_UnifiedCompliancePolicyUIAction xmlns="http://schemas.microsoft.com/sharepoint/v3" xsi:nil="true"/>
+    <Image xmlns="71af3243-3dd4-4a8d-8c0d-dd76da1f02a5">
+      <Url xsi:nil="true"/>
+      <Description xsi:nil="true"/>
+    </Image>
+    <Status xmlns="71af3243-3dd4-4a8d-8c0d-dd76da1f02a5">Not started</Status>
+    <Background xmlns="71af3243-3dd4-4a8d-8c0d-dd76da1f02a5">false</Background>
+    <_ip_UnifiedCompliancePolicyProperties xmlns="http://schemas.microsoft.com/sharepoint/v3" xsi:nil="true"/>
+    <ImageTagsTaxHTField xmlns="71af3243-3dd4-4a8d-8c0d-dd76da1f02a5">
+      <Terms xmlns="http://schemas.microsoft.com/office/infopath/2007/PartnerControls"/>
+    </ImageTagsTaxHTField>
+    <TaxCatchAll xmlns="230e9df3-be65-4c73-a93b-d1236ebd677e" xsi:nil="true"/>
+    <MediaServiceKeyPoints xmlns="71af3243-3dd4-4a8d-8c0d-dd76da1f02a5" xsi:nil="true"/>
+  </documentManagement>
+</p:properties>
 </file>
 
 <file path=customXml/itemProps1.xml><?xml version="1.0" encoding="utf-8"?>
-<ds:datastoreItem xmlns:ds="http://schemas.openxmlformats.org/officeDocument/2006/customXml" ds:itemID="{AF19A644-6410-4EC7-894C-877E70305DFF}">
+<ds:datastoreItem xmlns:ds="http://schemas.openxmlformats.org/officeDocument/2006/customXml" ds:itemID="{E9424615-5FE5-4F43-AE24-3BC9A0532687}">
   <ds:schemaRefs>
-    <ds:schemaRef ds:uri="http://schemas.microsoft.com/office/2006/metadata/properties"/>
-    <ds:schemaRef ds:uri="http://schemas.microsoft.com/office/infopath/2007/PartnerControls"/>
-    <ds:schemaRef ds:uri="http://schemas.microsoft.com/sharepoint/v3"/>
-    <ds:schemaRef ds:uri="71af3243-3dd4-4a8d-8c0d-dd76da1f02a5"/>
-    <ds:schemaRef ds:uri="230e9df3-be65-4c73-a93b-d1236ebd677e"/>
+    <ds:schemaRef ds:uri="http://schemas.microsoft.com/sharepoint/v3/contenttype/forms"/>
   </ds:schemaRefs>
 </ds:datastoreItem>
 </file>
@@ -10614,9 +10626,13 @@
 </file>
 
 <file path=customXml/itemProps3.xml><?xml version="1.0" encoding="utf-8"?>
-<ds:datastoreItem xmlns:ds="http://schemas.openxmlformats.org/officeDocument/2006/customXml" ds:itemID="{E9424615-5FE5-4F43-AE24-3BC9A0532687}">
+<ds:datastoreItem xmlns:ds="http://schemas.openxmlformats.org/officeDocument/2006/customXml" ds:itemID="{AF19A644-6410-4EC7-894C-877E70305DFF}">
   <ds:schemaRefs>
-    <ds:schemaRef ds:uri="http://schemas.microsoft.com/sharepoint/v3/contenttype/forms"/>
+    <ds:schemaRef ds:uri="http://schemas.microsoft.com/office/2006/metadata/properties"/>
+    <ds:schemaRef ds:uri="http://schemas.microsoft.com/office/infopath/2007/PartnerControls"/>
+    <ds:schemaRef ds:uri="http://schemas.microsoft.com/sharepoint/v3"/>
+    <ds:schemaRef ds:uri="71af3243-3dd4-4a8d-8c0d-dd76da1f02a5"/>
+    <ds:schemaRef ds:uri="230e9df3-be65-4c73-a93b-d1236ebd677e"/>
   </ds:schemaRefs>
 </ds:datastoreItem>
 </file>

</xml_diff>